<commit_message>
chore: remove employer references and add a golden rule
Scrub all references to the author's employer and work account from this
public personal repo:

- knowledge/formal-methods/fret-concepts-and-fretish.md: genericize the
  employer name and the proprietary tool/language names it referenced.
- experiments/Course-Embedded-System-II/build_deck.py: employer name in the
  bio slide and speaker notes -> P. The lowercase "a prover" mentions are
  course content (theorem prover) and stay.
- Slides.pptx / Slides-AI-edition.pptx: patch the slide XML in place to
  replace the work email with the personal one and the employer name with P.
- .gitignore: ignore runs/, which holds local harness transcripts.

Add the golden rule in AGENTS.md (imported by CLAUDE.md), summarized in
README.md and pinned at the top of .agents/napkin.md: no employer
information and no work-account reference may appear in this repository.

Co-Authored-By: Claude Opus 5 (1M context) <noreply@anthropic.com>
</commit_message>
<xml_diff>
--- a/experiments/Course-Embedded-System-II/Slides-AI-edition.pptx
+++ b/experiments/Course-Embedded-System-II/Slides-AI-edition.pptx
@@ -1313,7 +1313,7 @@
           <a:lstStyle/>
           <a:p>
             <a:r>
-              <a:t>A quick word on where I'm coming from: embedded software, a PhD and postdoc on formal modelling and analysis of embedded systems, and now formal methods at Prover.</a:t>
+              <a:t>A quick word on where I'm coming from: embedded software, a PhD and postdoc on formal modelling and analysis of embedded systems, and now formal methods at P.</a:t>
             </a:r>
           </a:p>
         </p:txBody>
@@ -6622,7 +6622,7 @@
                 </a:solidFill>
                 <a:latin typeface="Calibri"/>
               </a:rPr>
-              <a:t>rong.gu@prover.se</a:t>
+              <a:t>ronggufly@gmail.com</a:t>
             </a:r>
           </a:p>
           <a:p>
@@ -14198,7 +14198,7 @@
                 </a:solidFill>
                 <a:latin typeface="Calibri"/>
               </a:rPr>
-              <a:t>Rong Gu — Formal Methods Developer at Prover (2025 – now)</a:t>
+              <a:t>Rong Gu — Formal Methods Developer at P (2025 – now)</a:t>
             </a:r>
           </a:p>
           <a:p>
@@ -14353,7 +14353,7 @@
                 </a:solidFill>
                 <a:latin typeface="Calibri"/>
               </a:rPr>
-              <a:t>Contact:  rong.gu@prover.se</a:t>
+              <a:t>Contact:  ronggufly@gmail.com</a:t>
             </a:r>
           </a:p>
         </p:txBody>

</xml_diff>